<commit_message>
feat: 旧 PPT 外观写入、SmartArt matrix/radial 验收与 OLE 深度编辑 SDK（票据 012–015）
接替 #4 中 master 尚未覆盖、且经核对站得住的部分；005–007 已由 master 另行实现，016 未移植。

- 012：savePpt 写入首尾两色线性渐变（两端透明度分别写 fillOpacity / fillBackOpacity）、预设虚线、
  默认尺寸箭头、图片四边裁剪与形状名。fillAngle 的符号与 fillFocus 决定首尾色（LibreOffice
  ImportGradientColor），写入统一落在 [−360, 0)；读取 .ppt 时按同一规则还原，焦点 40–60 读为轴向渐变，
  并读取 fillBackOpacity、cropFrom* 与 wzName。图案填充在 OfficeArt 中是图案位图，没有预设记录可写，
  继续拒绝（#4 把图案索引写进 fillBackOpacity 槽位，未沿用）。
- 013：sample-smartart 增加 matrix1 / radial1 两页及解析、编辑验收。
- 014 / 015：OLE DOCX run 级改字与表格段落、XLSX 单元格样式与 sharedStrings 富文本。相对 #4 修正：
  段落文字按全部 w:t 拼接（超链接不丢）、val="0" / val="none" 视为关闭、写入颜色用 4 字节 ARGB、
  新建关系 Id 去重、去掉富文本时保留文字。官网入口与外部读取验证待补，票据保持 in-progress。

showcase.ppt 第 2、5 页快照随渐变方向与图片裁剪的读取修正更新（与源 PPTX 一致）；
官网首开闭包按实测上调 700B（.ppt 首次渲染必经代码）。

Co-Authored-By: Claude Opus 5.5 <noreply@anthropic.com>
</commit_message>
<xml_diff>
--- a/fixtures/sample-smartart-edit.pptx
+++ b/fixtures/sample-smartart-edit.pptx
@@ -11,6 +11,8 @@
     <p:sldId id="259" r:id="rId5"/>
     <p:sldId id="260" r:id="rId6"/>
     <p:sldId id="261" r:id="rId7"/>
+    <p:sldId id="262" r:id="rId8"/>
+    <p:sldId id="263" r:id="rId9"/>
   </p:sldIdLst>
   <p:sldSz cx="12192000" cy="6858000"/>
   <p:notesSz cx="6858000" cy="9144000"/>
@@ -161,6 +163,54 @@
 </dgm:colorsDef>
 </file>
 
+<file path=ppt/diagrams/colors7.xml><?xml version="1.0" encoding="utf-8"?>
+<dgm:colorsDef xmlns:dgm="http://schemas.openxmlformats.org/drawingml/2006/diagram" xmlns:a="http://schemas.openxmlformats.org/drawingml/2006/main" uniqueId="urn:test/colors">
+  <dgm:title val=""/>
+  <dgm:desc val=""/>
+  <dgm:styleLbl name="node0">
+    <dgm:fillClrLst meth="repeat">
+      <a:schemeClr val="accent1"/>
+      <a:schemeClr val="accent2"/>
+      <a:schemeClr val="accent3"/>
+      <a:schemeClr val="accent4"/>
+      <a:schemeClr val="accent5"/>
+      <a:schemeClr val="accent6"/>
+    </dgm:fillClrLst>
+    <dgm:linClrLst meth="repeat">
+      <a:schemeClr val="lt1"/>
+    </dgm:linClrLst>
+    <dgm:txLinClrLst/>
+    <dgm:txFillClrLst/>
+    <dgm:txEffectClrLst/>
+    <dgm:effectClrLst/>
+  </dgm:styleLbl>
+</dgm:colorsDef>
+</file>
+
+<file path=ppt/diagrams/colors8.xml><?xml version="1.0" encoding="utf-8"?>
+<dgm:colorsDef xmlns:dgm="http://schemas.openxmlformats.org/drawingml/2006/diagram" xmlns:a="http://schemas.openxmlformats.org/drawingml/2006/main" uniqueId="urn:test/colors">
+  <dgm:title val=""/>
+  <dgm:desc val=""/>
+  <dgm:styleLbl name="node0">
+    <dgm:fillClrLst meth="repeat">
+      <a:schemeClr val="accent1"/>
+      <a:schemeClr val="accent2"/>
+      <a:schemeClr val="accent3"/>
+      <a:schemeClr val="accent4"/>
+      <a:schemeClr val="accent5"/>
+      <a:schemeClr val="accent6"/>
+    </dgm:fillClrLst>
+    <dgm:linClrLst meth="repeat">
+      <a:schemeClr val="lt1"/>
+    </dgm:linClrLst>
+    <dgm:txLinClrLst/>
+    <dgm:txFillClrLst/>
+    <dgm:txEffectClrLst/>
+    <dgm:effectClrLst/>
+  </dgm:styleLbl>
+</dgm:colorsDef>
+</file>
+
 <file path=ppt/diagrams/data1.xml><?xml version="1.0" encoding="utf-8"?>
 <dgm:dataModel xmlns:dgm="http://schemas.openxmlformats.org/drawingml/2006/diagram" xmlns:a="http://schemas.openxmlformats.org/drawingml/2006/main">
   <dgm:ptLst>
@@ -781,6 +831,255 @@
     <dgm:cxn modelId="{777C7715-FE23-B83C-881A-B68874E31C0D}" srcId="0" destId="{676B8BB8-4CE7-267D-D520-DECA4811C8F1}" srcOrd="0" destOrd="0" parTransId="{4B54BE3E-8824-0F0C-8816-977EAC1FF1A1}" sibTransId="{BF792F85-12EE-C194-EEC2-59D8816C9DB9}"/>
     <dgm:cxn modelId="{A0011C07-9794-2091-CE3A-6B7555144A3B}" srcId="0" destId="{0480A93D-2E9B-094B-89E0-8E01976089AC}" srcOrd="1" destOrd="0" parTransId="{B964CCA5-D318-A3FB-454E-56D1C9E279D6}" sibTransId="{B420699A-2DDB-E17F-EF19-5D92ACDCD3F5}"/>
     <dgm:cxn modelId="{8C1D252E-3E04-9A35-E9E9-4A2E70C4D289}" srcId="0" destId="{8721D664-EF60-096A-A559-E1AA6C72CAF1}" srcOrd="2" destOrd="0" parTransId="{2ECB2D74-6EAF-4213-0214-A1A202490C85}" sibTransId="{E193203F-16E5-A81A-DA7A-CB1E6263F75B}"/>
+    <dgm:cxn modelId="{405B4841-6753-9D78-1CCF-C7EDFFDD41B1}" type="presOf" srcId="0" destId="{676B8BB8-4CE7-267D-D520-DECA4811C8F1}" srcOrd="0" destOrd="0"/>
+  </dgm:cxnLst>
+  <dgm:bg/>
+  <dgm:whole/>
+  <dgm:extLst>
+    <dgm:ext uri="preserve-smartart">
+      <keep xmlns="urn:test">未知数据扩展</keep>
+    </dgm:ext>
+  </dgm:extLst>
+</dgm:dataModel>
+</file>
+
+<file path=ppt/diagrams/data7.xml><?xml version="1.0" encoding="utf-8"?>
+<dgm:dataModel xmlns:dgm="http://schemas.openxmlformats.org/drawingml/2006/diagram" xmlns:a="http://schemas.openxmlformats.org/drawingml/2006/main">
+  <dgm:ptLst>
+    <dgm:pt modelId="0" type="doc">
+      <dgm:prSet/>
+      <dgm:spPr/>
+    </dgm:pt>
+    <dgm:pt modelId="{676B8BB8-4CE7-267D-D520-DECA4811C8F1}">
+      <dgm:prSet/>
+      <dgm:spPr/>
+      <dgm:t>
+        <a:bodyPr/>
+        <a:lstStyle/>
+        <a:p>
+          <a:r>
+            <a:rPr lang="zh-CN" sz="1400"/>
+            <a:t>左上</a:t>
+          </a:r>
+        </a:p>
+      </dgm:t>
+    </dgm:pt>
+    <dgm:pt modelId="{4B54BE3E-8824-0F0C-8816-977EAC1FF1A1}" type="parTrans" cxnId="{777C7715-FE23-B83C-881A-B68874E31C0D}">
+      <dgm:prSet/>
+      <dgm:spPr/>
+    </dgm:pt>
+    <dgm:pt modelId="{BF792F85-12EE-C194-EEC2-59D8816C9DB9}" type="sibTrans" cxnId="{777C7715-FE23-B83C-881A-B68874E31C0D}">
+      <dgm:prSet/>
+      <dgm:spPr/>
+    </dgm:pt>
+    <dgm:pt modelId="{0480A93D-2E9B-094B-89E0-8E01976089AC}">
+      <dgm:prSet/>
+      <dgm:spPr/>
+      <dgm:t>
+        <a:bodyPr/>
+        <a:lstStyle/>
+        <a:p>
+          <a:r>
+            <a:rPr lang="zh-CN" sz="1400"/>
+            <a:t>右上</a:t>
+          </a:r>
+        </a:p>
+      </dgm:t>
+    </dgm:pt>
+    <dgm:pt modelId="{B964CCA5-D318-A3FB-454E-56D1C9E279D6}" type="parTrans" cxnId="{A0011C07-9794-2091-CE3A-6B7555144A3B}">
+      <dgm:prSet/>
+      <dgm:spPr/>
+    </dgm:pt>
+    <dgm:pt modelId="{B420699A-2DDB-E17F-EF19-5D92ACDCD3F5}" type="sibTrans" cxnId="{A0011C07-9794-2091-CE3A-6B7555144A3B}">
+      <dgm:prSet/>
+      <dgm:spPr/>
+    </dgm:pt>
+    <dgm:pt modelId="{8721D664-EF60-096A-A559-E1AA6C72CAF1}">
+      <dgm:prSet/>
+      <dgm:spPr/>
+      <dgm:t>
+        <a:bodyPr/>
+        <a:lstStyle/>
+        <a:p>
+          <a:r>
+            <a:rPr lang="zh-CN" sz="1400"/>
+            <a:t>左下</a:t>
+          </a:r>
+        </a:p>
+      </dgm:t>
+    </dgm:pt>
+    <dgm:pt modelId="{2ECB2D74-6EAF-4213-0214-A1A202490C85}" type="parTrans" cxnId="{8C1D252E-3E04-9A35-E9E9-4A2E70C4D289}">
+      <dgm:prSet/>
+      <dgm:spPr/>
+    </dgm:pt>
+    <dgm:pt modelId="{E193203F-16E5-A81A-DA7A-CB1E6263F75B}" type="sibTrans" cxnId="{8C1D252E-3E04-9A35-E9E9-4A2E70C4D289}">
+      <dgm:prSet/>
+      <dgm:spPr/>
+    </dgm:pt>
+    <dgm:pt modelId="{88450B08-2EC4-DF2F-DCCD-3A626C6E489B}">
+      <dgm:prSet/>
+      <dgm:spPr/>
+      <dgm:t>
+        <a:bodyPr/>
+        <a:lstStyle/>
+        <a:p>
+          <a:r>
+            <a:rPr lang="zh-CN" sz="1400"/>
+            <a:t>右下</a:t>
+          </a:r>
+        </a:p>
+      </dgm:t>
+    </dgm:pt>
+    <dgm:pt modelId="{23D5B1E2-ACC6-204A-08B0-A46EFC43859C}" type="parTrans" cxnId="{9A795A5F-BB92-E034-063D-180FCF1DC882}">
+      <dgm:prSet/>
+      <dgm:spPr/>
+    </dgm:pt>
+    <dgm:pt modelId="{75A33DC7-D312-45BE-114C-E13F373CFA47}" type="sibTrans" cxnId="{9A795A5F-BB92-E034-063D-180FCF1DC882}">
+      <dgm:prSet/>
+      <dgm:spPr/>
+    </dgm:pt>
+  </dgm:ptLst>
+  <dgm:cxnLst>
+    <dgm:cxn modelId="{777C7715-FE23-B83C-881A-B68874E31C0D}" srcId="0" destId="{676B8BB8-4CE7-267D-D520-DECA4811C8F1}" srcOrd="0" destOrd="0" parTransId="{4B54BE3E-8824-0F0C-8816-977EAC1FF1A1}" sibTransId="{BF792F85-12EE-C194-EEC2-59D8816C9DB9}"/>
+    <dgm:cxn modelId="{A0011C07-9794-2091-CE3A-6B7555144A3B}" srcId="0" destId="{0480A93D-2E9B-094B-89E0-8E01976089AC}" srcOrd="1" destOrd="0" parTransId="{B964CCA5-D318-A3FB-454E-56D1C9E279D6}" sibTransId="{B420699A-2DDB-E17F-EF19-5D92ACDCD3F5}"/>
+    <dgm:cxn modelId="{8C1D252E-3E04-9A35-E9E9-4A2E70C4D289}" srcId="0" destId="{8721D664-EF60-096A-A559-E1AA6C72CAF1}" srcOrd="2" destOrd="0" parTransId="{2ECB2D74-6EAF-4213-0214-A1A202490C85}" sibTransId="{E193203F-16E5-A81A-DA7A-CB1E6263F75B}"/>
+    <dgm:cxn modelId="{9A795A5F-BB92-E034-063D-180FCF1DC882}" srcId="0" destId="{88450B08-2EC4-DF2F-DCCD-3A626C6E489B}" srcOrd="3" destOrd="0" parTransId="{23D5B1E2-ACC6-204A-08B0-A46EFC43859C}" sibTransId="{75A33DC7-D312-45BE-114C-E13F373CFA47}"/>
+    <dgm:cxn modelId="{405B4841-6753-9D78-1CCF-C7EDFFDD41B1}" type="presOf" srcId="0" destId="{676B8BB8-4CE7-267D-D520-DECA4811C8F1}" srcOrd="0" destOrd="0"/>
+  </dgm:cxnLst>
+  <dgm:bg/>
+  <dgm:whole/>
+  <dgm:extLst>
+    <dgm:ext uri="preserve-smartart">
+      <keep xmlns="urn:test">未知数据扩展</keep>
+    </dgm:ext>
+  </dgm:extLst>
+</dgm:dataModel>
+</file>
+
+<file path=ppt/diagrams/data8.xml><?xml version="1.0" encoding="utf-8"?>
+<dgm:dataModel xmlns:dgm="http://schemas.openxmlformats.org/drawingml/2006/diagram" xmlns:a="http://schemas.openxmlformats.org/drawingml/2006/main">
+  <dgm:ptLst>
+    <dgm:pt modelId="0" type="doc">
+      <dgm:prSet/>
+      <dgm:spPr/>
+    </dgm:pt>
+    <dgm:pt modelId="{676B8BB8-4CE7-267D-D520-DECA4811C8F1}">
+      <dgm:prSet/>
+      <dgm:spPr/>
+      <dgm:t>
+        <a:bodyPr/>
+        <a:lstStyle/>
+        <a:p>
+          <a:r>
+            <a:rPr lang="zh-CN" sz="1400"/>
+            <a:t>中心</a:t>
+          </a:r>
+        </a:p>
+      </dgm:t>
+    </dgm:pt>
+    <dgm:pt modelId="{4B54BE3E-8824-0F0C-8816-977EAC1FF1A1}" type="parTrans" cxnId="{777C7715-FE23-B83C-881A-B68874E31C0D}">
+      <dgm:prSet/>
+      <dgm:spPr/>
+    </dgm:pt>
+    <dgm:pt modelId="{BF792F85-12EE-C194-EEC2-59D8816C9DB9}" type="sibTrans" cxnId="{777C7715-FE23-B83C-881A-B68874E31C0D}">
+      <dgm:prSet/>
+      <dgm:spPr/>
+    </dgm:pt>
+    <dgm:pt modelId="{0480A93D-2E9B-094B-89E0-8E01976089AC}">
+      <dgm:prSet/>
+      <dgm:spPr/>
+      <dgm:t>
+        <a:bodyPr/>
+        <a:lstStyle/>
+        <a:p>
+          <a:r>
+            <a:rPr lang="zh-CN" sz="1400"/>
+            <a:t>北</a:t>
+          </a:r>
+        </a:p>
+      </dgm:t>
+    </dgm:pt>
+    <dgm:pt modelId="{B964CCA5-D318-A3FB-454E-56D1C9E279D6}" type="parTrans" cxnId="{A0011C07-9794-2091-CE3A-6B7555144A3B}">
+      <dgm:prSet/>
+      <dgm:spPr/>
+    </dgm:pt>
+    <dgm:pt modelId="{B420699A-2DDB-E17F-EF19-5D92ACDCD3F5}" type="sibTrans" cxnId="{A0011C07-9794-2091-CE3A-6B7555144A3B}">
+      <dgm:prSet/>
+      <dgm:spPr/>
+    </dgm:pt>
+    <dgm:pt modelId="{8721D664-EF60-096A-A559-E1AA6C72CAF1}">
+      <dgm:prSet/>
+      <dgm:spPr/>
+      <dgm:t>
+        <a:bodyPr/>
+        <a:lstStyle/>
+        <a:p>
+          <a:r>
+            <a:rPr lang="zh-CN" sz="1400"/>
+            <a:t>东</a:t>
+          </a:r>
+        </a:p>
+      </dgm:t>
+    </dgm:pt>
+    <dgm:pt modelId="{2ECB2D74-6EAF-4213-0214-A1A202490C85}" type="parTrans" cxnId="{8C1D252E-3E04-9A35-E9E9-4A2E70C4D289}">
+      <dgm:prSet/>
+      <dgm:spPr/>
+    </dgm:pt>
+    <dgm:pt modelId="{E193203F-16E5-A81A-DA7A-CB1E6263F75B}" type="sibTrans" cxnId="{8C1D252E-3E04-9A35-E9E9-4A2E70C4D289}">
+      <dgm:prSet/>
+      <dgm:spPr/>
+    </dgm:pt>
+    <dgm:pt modelId="{88450B08-2EC4-DF2F-DCCD-3A626C6E489B}">
+      <dgm:prSet/>
+      <dgm:spPr/>
+      <dgm:t>
+        <a:bodyPr/>
+        <a:lstStyle/>
+        <a:p>
+          <a:r>
+            <a:rPr lang="zh-CN" sz="1400"/>
+            <a:t>南</a:t>
+          </a:r>
+        </a:p>
+      </dgm:t>
+    </dgm:pt>
+    <dgm:pt modelId="{23D5B1E2-ACC6-204A-08B0-A46EFC43859C}" type="parTrans" cxnId="{9A795A5F-BB92-E034-063D-180FCF1DC882}">
+      <dgm:prSet/>
+      <dgm:spPr/>
+    </dgm:pt>
+    <dgm:pt modelId="{75A33DC7-D312-45BE-114C-E13F373CFA47}" type="sibTrans" cxnId="{9A795A5F-BB92-E034-063D-180FCF1DC882}">
+      <dgm:prSet/>
+      <dgm:spPr/>
+    </dgm:pt>
+    <dgm:pt modelId="{4A8456F1-0E37-6897-78CE-F532AB6A7374}">
+      <dgm:prSet/>
+      <dgm:spPr/>
+      <dgm:t>
+        <a:bodyPr/>
+        <a:lstStyle/>
+        <a:p>
+          <a:r>
+            <a:rPr lang="zh-CN" sz="1400"/>
+            <a:t>西</a:t>
+          </a:r>
+        </a:p>
+      </dgm:t>
+    </dgm:pt>
+    <dgm:pt modelId="{AA90E599-BCAE-0EA2-E1DD-391FC8A5AE74}" type="parTrans" cxnId="{5D498542-7588-3947-C0D0-BC75B4A655BC}">
+      <dgm:prSet/>
+      <dgm:spPr/>
+    </dgm:pt>
+    <dgm:pt modelId="{8D06E3C4-C98F-56FA-F0E8-14727A9DDF13}" type="sibTrans" cxnId="{5D498542-7588-3947-C0D0-BC75B4A655BC}">
+      <dgm:prSet/>
+      <dgm:spPr/>
+    </dgm:pt>
+  </dgm:ptLst>
+  <dgm:cxnLst>
+    <dgm:cxn modelId="{777C7715-FE23-B83C-881A-B68874E31C0D}" srcId="0" destId="{676B8BB8-4CE7-267D-D520-DECA4811C8F1}" srcOrd="0" destOrd="0" parTransId="{4B54BE3E-8824-0F0C-8816-977EAC1FF1A1}" sibTransId="{BF792F85-12EE-C194-EEC2-59D8816C9DB9}"/>
+    <dgm:cxn modelId="{A0011C07-9794-2091-CE3A-6B7555144A3B}" srcId="{676B8BB8-4CE7-267D-D520-DECA4811C8F1}" destId="{0480A93D-2E9B-094B-89E0-8E01976089AC}" srcOrd="0" destOrd="0" parTransId="{B964CCA5-D318-A3FB-454E-56D1C9E279D6}" sibTransId="{B420699A-2DDB-E17F-EF19-5D92ACDCD3F5}"/>
+    <dgm:cxn modelId="{8C1D252E-3E04-9A35-E9E9-4A2E70C4D289}" srcId="{676B8BB8-4CE7-267D-D520-DECA4811C8F1}" destId="{8721D664-EF60-096A-A559-E1AA6C72CAF1}" srcOrd="1" destOrd="0" parTransId="{2ECB2D74-6EAF-4213-0214-A1A202490C85}" sibTransId="{E193203F-16E5-A81A-DA7A-CB1E6263F75B}"/>
+    <dgm:cxn modelId="{9A795A5F-BB92-E034-063D-180FCF1DC882}" srcId="{676B8BB8-4CE7-267D-D520-DECA4811C8F1}" destId="{88450B08-2EC4-DF2F-DCCD-3A626C6E489B}" srcOrd="2" destOrd="0" parTransId="{23D5B1E2-ACC6-204A-08B0-A46EFC43859C}" sibTransId="{75A33DC7-D312-45BE-114C-E13F373CFA47}"/>
+    <dgm:cxn modelId="{5D498542-7588-3947-C0D0-BC75B4A655BC}" srcId="{676B8BB8-4CE7-267D-D520-DECA4811C8F1}" destId="{4A8456F1-0E37-6897-78CE-F532AB6A7374}" srcOrd="3" destOrd="0" parTransId="{AA90E599-BCAE-0EA2-E1DD-391FC8A5AE74}" sibTransId="{8D06E3C4-C98F-56FA-F0E8-14727A9DDF13}"/>
     <dgm:cxn modelId="{405B4841-6753-9D78-1CCF-C7EDFFDD41B1}" type="presOf" srcId="0" destId="{676B8BB8-4CE7-267D-D520-DECA4811C8F1}" srcOrd="0" destOrd="0"/>
   </dgm:cxnLst>
   <dgm:bg/>
@@ -990,6 +1289,34 @@
 </dgm:layoutDef>
 </file>
 
+<file path=ppt/diagrams/layout7.xml><?xml version="1.0" encoding="utf-8"?>
+<dgm:layoutDef xmlns:dgm="http://schemas.openxmlformats.org/drawingml/2006/diagram" xmlns:a="http://schemas.openxmlformats.org/drawingml/2006/main" uniqueId="urn:microsoft.com/office/officeart/2005/8/layout/matrix1">
+  <dgm:title val=""/>
+  <dgm:desc val=""/>
+  <dgm:layoutNode name="root">
+    <dgm:alg type="snake"/>
+    <dgm:shape xmlns:r="http://schemas.openxmlformats.org/officeDocument/2006/relationships" type="none"/>
+    <dgm:presOf/>
+    <dgm:constrLst/>
+    <dgm:ruleLst/>
+  </dgm:layoutNode>
+</dgm:layoutDef>
+</file>
+
+<file path=ppt/diagrams/layout8.xml><?xml version="1.0" encoding="utf-8"?>
+<dgm:layoutDef xmlns:dgm="http://schemas.openxmlformats.org/drawingml/2006/diagram" xmlns:a="http://schemas.openxmlformats.org/drawingml/2006/main" uniqueId="urn:microsoft.com/office/officeart/2005/8/layout/radial1">
+  <dgm:title val=""/>
+  <dgm:desc val=""/>
+  <dgm:layoutNode name="root">
+    <dgm:alg type="sp"/>
+    <dgm:shape xmlns:r="http://schemas.openxmlformats.org/officeDocument/2006/relationships" type="none"/>
+    <dgm:presOf/>
+    <dgm:constrLst/>
+    <dgm:ruleLst/>
+  </dgm:layoutNode>
+</dgm:layoutDef>
+</file>
+
 <file path=ppt/diagrams/quickStyle1.xml><?xml version="1.0" encoding="utf-8"?>
 <dgm:styleDef xmlns:dgm="http://schemas.openxmlformats.org/drawingml/2006/diagram" xmlns:a="http://schemas.openxmlformats.org/drawingml/2006/main" uniqueId="urn:test/style">
   <dgm:title val=""/>
@@ -1091,6 +1418,46 @@
 </file>
 
 <file path=ppt/diagrams/quickStyle6.xml><?xml version="1.0" encoding="utf-8"?>
+<dgm:styleDef xmlns:dgm="http://schemas.openxmlformats.org/drawingml/2006/diagram" xmlns:a="http://schemas.openxmlformats.org/drawingml/2006/main" uniqueId="urn:test/style">
+  <dgm:title val=""/>
+  <dgm:desc val=""/>
+  <dgm:scene3d>
+    <a:camera prst="orthographicFront"/>
+    <a:lightRig rig="threePt" dir="t"/>
+  </dgm:scene3d>
+  <dgm:styleLbl name="node0">
+    <dgm:scene3d>
+      <a:camera prst="orthographicFront"/>
+      <a:lightRig rig="threePt" dir="t"/>
+    </dgm:scene3d>
+    <dgm:sp3d/>
+    <dgm:txPr/>
+    <dgm:style/>
+  </dgm:styleLbl>
+</dgm:styleDef>
+</file>
+
+<file path=ppt/diagrams/quickStyle7.xml><?xml version="1.0" encoding="utf-8"?>
+<dgm:styleDef xmlns:dgm="http://schemas.openxmlformats.org/drawingml/2006/diagram" xmlns:a="http://schemas.openxmlformats.org/drawingml/2006/main" uniqueId="urn:test/style">
+  <dgm:title val=""/>
+  <dgm:desc val=""/>
+  <dgm:scene3d>
+    <a:camera prst="orthographicFront"/>
+    <a:lightRig rig="threePt" dir="t"/>
+  </dgm:scene3d>
+  <dgm:styleLbl name="node0">
+    <dgm:scene3d>
+      <a:camera prst="orthographicFront"/>
+      <a:lightRig rig="threePt" dir="t"/>
+    </dgm:scene3d>
+    <dgm:sp3d/>
+    <dgm:txPr/>
+    <dgm:style/>
+  </dgm:styleLbl>
+</dgm:styleDef>
+</file>
+
+<file path=ppt/diagrams/quickStyle8.xml><?xml version="1.0" encoding="utf-8"?>
 <dgm:styleDef xmlns:dgm="http://schemas.openxmlformats.org/drawingml/2006/diagram" xmlns:a="http://schemas.openxmlformats.org/drawingml/2006/main" uniqueId="urn:test/style">
   <dgm:title val=""/>
   <dgm:desc val=""/>
@@ -1606,6 +1973,150 @@
       <p:graphicFrame>
         <p:nvGraphicFramePr>
           <p:cNvPr id="505" name="SmartArt5"/>
+          <p:cNvGraphicFramePr/>
+          <p:nvPr/>
+        </p:nvGraphicFramePr>
+        <p:xfrm>
+          <a:off x="1143000" y="952500"/>
+          <a:ext cx="9906000" cy="4953000"/>
+        </p:xfrm>
+        <a:graphic>
+          <a:graphicData uri="http://schemas.openxmlformats.org/drawingml/2006/diagram">
+            <dgm:relIds xmlns:dgm="http://schemas.openxmlformats.org/drawingml/2006/diagram" xmlns:r="http://schemas.openxmlformats.org/officeDocument/2006/relationships" r:dm="rId2" r:lo="rId3" r:qs="rId4" r:cs="rId5"/>
+          </a:graphicData>
+        </a:graphic>
+      </p:graphicFrame>
+    </p:spTree>
+  </p:cSld>
+  <p:clrMapOvr>
+    <a:masterClrMapping/>
+  </p:clrMapOvr>
+</p:sld>
+</file>
+
+<file path=ppt/slides/slide7.xml><?xml version="1.0" encoding="utf-8"?>
+<p:sld xmlns:a="http://schemas.openxmlformats.org/drawingml/2006/main" xmlns:r="http://schemas.openxmlformats.org/officeDocument/2006/relationships" xmlns:p="http://schemas.openxmlformats.org/presentationml/2006/main">
+  <p:cSld>
+    <p:spTree>
+      <p:nvGrpSpPr>
+        <p:cNvPr id="1" name=""/>
+        <p:cNvGrpSpPr/>
+        <p:nvPr/>
+      </p:nvGrpSpPr>
+      <p:grpSpPr>
+        <a:xfrm>
+          <a:off x="0" y="0"/>
+          <a:ext cx="0" cy="0"/>
+          <a:chOff x="0" y="0"/>
+          <a:chExt cx="0" cy="0"/>
+        </a:xfrm>
+      </p:grpSpPr>
+      <p:sp>
+        <p:nvSpPr>
+          <p:cNvPr id="107" name="sp"/>
+          <p:cNvSpPr/>
+          <p:nvPr/>
+        </p:nvSpPr>
+        <p:spPr>
+          <a:xfrm>
+            <a:off x="381000" y="228600"/>
+            <a:ext cx="8572500" cy="323850"/>
+          </a:xfrm>
+          <a:prstGeom prst="rect">
+            <a:avLst/>
+          </a:prstGeom>
+          <a:noFill/>
+        </p:spPr>
+        <p:txBody>
+          <a:bodyPr anchor="ctr"/>
+          <a:lstStyle/>
+          <a:p>
+            <a:r>
+              <a:rPr sz="1600" b="1">
+                <a:solidFill>
+                  <a:schemeClr val="tx2"/>
+                </a:solidFill>
+              </a:rPr>
+              <a:t>无 drawing · 矩阵（matrix1→snake）</a:t>
+            </a:r>
+          </a:p>
+        </p:txBody>
+      </p:sp>
+      <p:graphicFrame>
+        <p:nvGraphicFramePr>
+          <p:cNvPr id="506" name="SmartArt6"/>
+          <p:cNvGraphicFramePr/>
+          <p:nvPr/>
+        </p:nvGraphicFramePr>
+        <p:xfrm>
+          <a:off x="1143000" y="952500"/>
+          <a:ext cx="9906000" cy="4953000"/>
+        </p:xfrm>
+        <a:graphic>
+          <a:graphicData uri="http://schemas.openxmlformats.org/drawingml/2006/diagram">
+            <dgm:relIds xmlns:dgm="http://schemas.openxmlformats.org/drawingml/2006/diagram" xmlns:r="http://schemas.openxmlformats.org/officeDocument/2006/relationships" r:dm="rId2" r:lo="rId3" r:qs="rId4" r:cs="rId5"/>
+          </a:graphicData>
+        </a:graphic>
+      </p:graphicFrame>
+    </p:spTree>
+  </p:cSld>
+  <p:clrMapOvr>
+    <a:masterClrMapping/>
+  </p:clrMapOvr>
+</p:sld>
+</file>
+
+<file path=ppt/slides/slide8.xml><?xml version="1.0" encoding="utf-8"?>
+<p:sld xmlns:a="http://schemas.openxmlformats.org/drawingml/2006/main" xmlns:r="http://schemas.openxmlformats.org/officeDocument/2006/relationships" xmlns:p="http://schemas.openxmlformats.org/presentationml/2006/main">
+  <p:cSld>
+    <p:spTree>
+      <p:nvGrpSpPr>
+        <p:cNvPr id="1" name=""/>
+        <p:cNvGrpSpPr/>
+        <p:nvPr/>
+      </p:nvGrpSpPr>
+      <p:grpSpPr>
+        <a:xfrm>
+          <a:off x="0" y="0"/>
+          <a:ext cx="0" cy="0"/>
+          <a:chOff x="0" y="0"/>
+          <a:chExt cx="0" cy="0"/>
+        </a:xfrm>
+      </p:grpSpPr>
+      <p:sp>
+        <p:nvSpPr>
+          <p:cNvPr id="108" name="sp"/>
+          <p:cNvSpPr/>
+          <p:nvPr/>
+        </p:nvSpPr>
+        <p:spPr>
+          <a:xfrm>
+            <a:off x="381000" y="228600"/>
+            <a:ext cx="8572500" cy="323850"/>
+          </a:xfrm>
+          <a:prstGeom prst="rect">
+            <a:avLst/>
+          </a:prstGeom>
+          <a:noFill/>
+        </p:spPr>
+        <p:txBody>
+          <a:bodyPr anchor="ctr"/>
+          <a:lstStyle/>
+          <a:p>
+            <a:r>
+              <a:rPr sz="1600" b="1">
+                <a:solidFill>
+                  <a:schemeClr val="tx2"/>
+                </a:solidFill>
+              </a:rPr>
+              <a:t>无 drawing · 径向（radial1）</a:t>
+            </a:r>
+          </a:p>
+        </p:txBody>
+      </p:sp>
+      <p:graphicFrame>
+        <p:nvGraphicFramePr>
+          <p:cNvPr id="507" name="SmartArt7"/>
           <p:cNvGraphicFramePr/>
           <p:nvPr/>
         </p:nvGraphicFramePr>

</xml_diff>

<commit_message>
feat: 旧 PPT 外观写入、SmartArt matrix/radial 验收与 OLE 深度编辑 SDK (#19)
接替 #4 中 master 尚未覆盖、且经核对站得住的部分；005–007 已由 master 另行实现，016 未移植。

- 012：savePpt 写入首尾两色线性渐变（两端透明度分别写 fillOpacity / fillBackOpacity）、预设虚线、
  默认尺寸箭头、图片四边裁剪与形状名。fillAngle 的符号与 fillFocus 决定首尾色（LibreOffice
  ImportGradientColor），写入统一落在 [−360, 0)；读取 .ppt 时按同一规则还原，焦点 40–60 读为轴向渐变，
  并读取 fillBackOpacity、cropFrom* 与 wzName。图案填充在 OfficeArt 中是图案位图，没有预设记录可写，
  继续拒绝（#4 把图案索引写进 fillBackOpacity 槽位，未沿用）。
- 013：sample-smartart 增加 matrix1 / radial1 两页及解析、编辑验收。
- 014 / 015：OLE DOCX run 级改字与表格段落、XLSX 单元格样式与 sharedStrings 富文本。相对 #4 修正：
  段落文字按全部 w:t 拼接（超链接不丢）、val="0" / val="none" 视为关闭、写入颜色用 4 字节 ARGB、
  新建关系 Id 去重、去掉富文本时保留文字。官网入口与外部读取验证待补，票据保持 in-progress。

showcase.ppt 第 2、5 页快照随渐变方向与图片裁剪的读取修正更新（与源 PPTX 一致）；
官网首开闭包按实测上调 700B（.ppt 首次渲染必经代码）。

Co-authored-by: Claude Opus 5.5 <noreply@anthropic.com>
</commit_message>
<xml_diff>
--- a/fixtures/sample-smartart-edit.pptx
+++ b/fixtures/sample-smartart-edit.pptx
@@ -11,6 +11,8 @@
     <p:sldId id="259" r:id="rId5"/>
     <p:sldId id="260" r:id="rId6"/>
     <p:sldId id="261" r:id="rId7"/>
+    <p:sldId id="262" r:id="rId8"/>
+    <p:sldId id="263" r:id="rId9"/>
   </p:sldIdLst>
   <p:sldSz cx="12192000" cy="6858000"/>
   <p:notesSz cx="6858000" cy="9144000"/>
@@ -161,6 +163,54 @@
 </dgm:colorsDef>
 </file>
 
+<file path=ppt/diagrams/colors7.xml><?xml version="1.0" encoding="utf-8"?>
+<dgm:colorsDef xmlns:dgm="http://schemas.openxmlformats.org/drawingml/2006/diagram" xmlns:a="http://schemas.openxmlformats.org/drawingml/2006/main" uniqueId="urn:test/colors">
+  <dgm:title val=""/>
+  <dgm:desc val=""/>
+  <dgm:styleLbl name="node0">
+    <dgm:fillClrLst meth="repeat">
+      <a:schemeClr val="accent1"/>
+      <a:schemeClr val="accent2"/>
+      <a:schemeClr val="accent3"/>
+      <a:schemeClr val="accent4"/>
+      <a:schemeClr val="accent5"/>
+      <a:schemeClr val="accent6"/>
+    </dgm:fillClrLst>
+    <dgm:linClrLst meth="repeat">
+      <a:schemeClr val="lt1"/>
+    </dgm:linClrLst>
+    <dgm:txLinClrLst/>
+    <dgm:txFillClrLst/>
+    <dgm:txEffectClrLst/>
+    <dgm:effectClrLst/>
+  </dgm:styleLbl>
+</dgm:colorsDef>
+</file>
+
+<file path=ppt/diagrams/colors8.xml><?xml version="1.0" encoding="utf-8"?>
+<dgm:colorsDef xmlns:dgm="http://schemas.openxmlformats.org/drawingml/2006/diagram" xmlns:a="http://schemas.openxmlformats.org/drawingml/2006/main" uniqueId="urn:test/colors">
+  <dgm:title val=""/>
+  <dgm:desc val=""/>
+  <dgm:styleLbl name="node0">
+    <dgm:fillClrLst meth="repeat">
+      <a:schemeClr val="accent1"/>
+      <a:schemeClr val="accent2"/>
+      <a:schemeClr val="accent3"/>
+      <a:schemeClr val="accent4"/>
+      <a:schemeClr val="accent5"/>
+      <a:schemeClr val="accent6"/>
+    </dgm:fillClrLst>
+    <dgm:linClrLst meth="repeat">
+      <a:schemeClr val="lt1"/>
+    </dgm:linClrLst>
+    <dgm:txLinClrLst/>
+    <dgm:txFillClrLst/>
+    <dgm:txEffectClrLst/>
+    <dgm:effectClrLst/>
+  </dgm:styleLbl>
+</dgm:colorsDef>
+</file>
+
 <file path=ppt/diagrams/data1.xml><?xml version="1.0" encoding="utf-8"?>
 <dgm:dataModel xmlns:dgm="http://schemas.openxmlformats.org/drawingml/2006/diagram" xmlns:a="http://schemas.openxmlformats.org/drawingml/2006/main">
   <dgm:ptLst>
@@ -781,6 +831,255 @@
     <dgm:cxn modelId="{777C7715-FE23-B83C-881A-B68874E31C0D}" srcId="0" destId="{676B8BB8-4CE7-267D-D520-DECA4811C8F1}" srcOrd="0" destOrd="0" parTransId="{4B54BE3E-8824-0F0C-8816-977EAC1FF1A1}" sibTransId="{BF792F85-12EE-C194-EEC2-59D8816C9DB9}"/>
     <dgm:cxn modelId="{A0011C07-9794-2091-CE3A-6B7555144A3B}" srcId="0" destId="{0480A93D-2E9B-094B-89E0-8E01976089AC}" srcOrd="1" destOrd="0" parTransId="{B964CCA5-D318-A3FB-454E-56D1C9E279D6}" sibTransId="{B420699A-2DDB-E17F-EF19-5D92ACDCD3F5}"/>
     <dgm:cxn modelId="{8C1D252E-3E04-9A35-E9E9-4A2E70C4D289}" srcId="0" destId="{8721D664-EF60-096A-A559-E1AA6C72CAF1}" srcOrd="2" destOrd="0" parTransId="{2ECB2D74-6EAF-4213-0214-A1A202490C85}" sibTransId="{E193203F-16E5-A81A-DA7A-CB1E6263F75B}"/>
+    <dgm:cxn modelId="{405B4841-6753-9D78-1CCF-C7EDFFDD41B1}" type="presOf" srcId="0" destId="{676B8BB8-4CE7-267D-D520-DECA4811C8F1}" srcOrd="0" destOrd="0"/>
+  </dgm:cxnLst>
+  <dgm:bg/>
+  <dgm:whole/>
+  <dgm:extLst>
+    <dgm:ext uri="preserve-smartart">
+      <keep xmlns="urn:test">未知数据扩展</keep>
+    </dgm:ext>
+  </dgm:extLst>
+</dgm:dataModel>
+</file>
+
+<file path=ppt/diagrams/data7.xml><?xml version="1.0" encoding="utf-8"?>
+<dgm:dataModel xmlns:dgm="http://schemas.openxmlformats.org/drawingml/2006/diagram" xmlns:a="http://schemas.openxmlformats.org/drawingml/2006/main">
+  <dgm:ptLst>
+    <dgm:pt modelId="0" type="doc">
+      <dgm:prSet/>
+      <dgm:spPr/>
+    </dgm:pt>
+    <dgm:pt modelId="{676B8BB8-4CE7-267D-D520-DECA4811C8F1}">
+      <dgm:prSet/>
+      <dgm:spPr/>
+      <dgm:t>
+        <a:bodyPr/>
+        <a:lstStyle/>
+        <a:p>
+          <a:r>
+            <a:rPr lang="zh-CN" sz="1400"/>
+            <a:t>左上</a:t>
+          </a:r>
+        </a:p>
+      </dgm:t>
+    </dgm:pt>
+    <dgm:pt modelId="{4B54BE3E-8824-0F0C-8816-977EAC1FF1A1}" type="parTrans" cxnId="{777C7715-FE23-B83C-881A-B68874E31C0D}">
+      <dgm:prSet/>
+      <dgm:spPr/>
+    </dgm:pt>
+    <dgm:pt modelId="{BF792F85-12EE-C194-EEC2-59D8816C9DB9}" type="sibTrans" cxnId="{777C7715-FE23-B83C-881A-B68874E31C0D}">
+      <dgm:prSet/>
+      <dgm:spPr/>
+    </dgm:pt>
+    <dgm:pt modelId="{0480A93D-2E9B-094B-89E0-8E01976089AC}">
+      <dgm:prSet/>
+      <dgm:spPr/>
+      <dgm:t>
+        <a:bodyPr/>
+        <a:lstStyle/>
+        <a:p>
+          <a:r>
+            <a:rPr lang="zh-CN" sz="1400"/>
+            <a:t>右上</a:t>
+          </a:r>
+        </a:p>
+      </dgm:t>
+    </dgm:pt>
+    <dgm:pt modelId="{B964CCA5-D318-A3FB-454E-56D1C9E279D6}" type="parTrans" cxnId="{A0011C07-9794-2091-CE3A-6B7555144A3B}">
+      <dgm:prSet/>
+      <dgm:spPr/>
+    </dgm:pt>
+    <dgm:pt modelId="{B420699A-2DDB-E17F-EF19-5D92ACDCD3F5}" type="sibTrans" cxnId="{A0011C07-9794-2091-CE3A-6B7555144A3B}">
+      <dgm:prSet/>
+      <dgm:spPr/>
+    </dgm:pt>
+    <dgm:pt modelId="{8721D664-EF60-096A-A559-E1AA6C72CAF1}">
+      <dgm:prSet/>
+      <dgm:spPr/>
+      <dgm:t>
+        <a:bodyPr/>
+        <a:lstStyle/>
+        <a:p>
+          <a:r>
+            <a:rPr lang="zh-CN" sz="1400"/>
+            <a:t>左下</a:t>
+          </a:r>
+        </a:p>
+      </dgm:t>
+    </dgm:pt>
+    <dgm:pt modelId="{2ECB2D74-6EAF-4213-0214-A1A202490C85}" type="parTrans" cxnId="{8C1D252E-3E04-9A35-E9E9-4A2E70C4D289}">
+      <dgm:prSet/>
+      <dgm:spPr/>
+    </dgm:pt>
+    <dgm:pt modelId="{E193203F-16E5-A81A-DA7A-CB1E6263F75B}" type="sibTrans" cxnId="{8C1D252E-3E04-9A35-E9E9-4A2E70C4D289}">
+      <dgm:prSet/>
+      <dgm:spPr/>
+    </dgm:pt>
+    <dgm:pt modelId="{88450B08-2EC4-DF2F-DCCD-3A626C6E489B}">
+      <dgm:prSet/>
+      <dgm:spPr/>
+      <dgm:t>
+        <a:bodyPr/>
+        <a:lstStyle/>
+        <a:p>
+          <a:r>
+            <a:rPr lang="zh-CN" sz="1400"/>
+            <a:t>右下</a:t>
+          </a:r>
+        </a:p>
+      </dgm:t>
+    </dgm:pt>
+    <dgm:pt modelId="{23D5B1E2-ACC6-204A-08B0-A46EFC43859C}" type="parTrans" cxnId="{9A795A5F-BB92-E034-063D-180FCF1DC882}">
+      <dgm:prSet/>
+      <dgm:spPr/>
+    </dgm:pt>
+    <dgm:pt modelId="{75A33DC7-D312-45BE-114C-E13F373CFA47}" type="sibTrans" cxnId="{9A795A5F-BB92-E034-063D-180FCF1DC882}">
+      <dgm:prSet/>
+      <dgm:spPr/>
+    </dgm:pt>
+  </dgm:ptLst>
+  <dgm:cxnLst>
+    <dgm:cxn modelId="{777C7715-FE23-B83C-881A-B68874E31C0D}" srcId="0" destId="{676B8BB8-4CE7-267D-D520-DECA4811C8F1}" srcOrd="0" destOrd="0" parTransId="{4B54BE3E-8824-0F0C-8816-977EAC1FF1A1}" sibTransId="{BF792F85-12EE-C194-EEC2-59D8816C9DB9}"/>
+    <dgm:cxn modelId="{A0011C07-9794-2091-CE3A-6B7555144A3B}" srcId="0" destId="{0480A93D-2E9B-094B-89E0-8E01976089AC}" srcOrd="1" destOrd="0" parTransId="{B964CCA5-D318-A3FB-454E-56D1C9E279D6}" sibTransId="{B420699A-2DDB-E17F-EF19-5D92ACDCD3F5}"/>
+    <dgm:cxn modelId="{8C1D252E-3E04-9A35-E9E9-4A2E70C4D289}" srcId="0" destId="{8721D664-EF60-096A-A559-E1AA6C72CAF1}" srcOrd="2" destOrd="0" parTransId="{2ECB2D74-6EAF-4213-0214-A1A202490C85}" sibTransId="{E193203F-16E5-A81A-DA7A-CB1E6263F75B}"/>
+    <dgm:cxn modelId="{9A795A5F-BB92-E034-063D-180FCF1DC882}" srcId="0" destId="{88450B08-2EC4-DF2F-DCCD-3A626C6E489B}" srcOrd="3" destOrd="0" parTransId="{23D5B1E2-ACC6-204A-08B0-A46EFC43859C}" sibTransId="{75A33DC7-D312-45BE-114C-E13F373CFA47}"/>
+    <dgm:cxn modelId="{405B4841-6753-9D78-1CCF-C7EDFFDD41B1}" type="presOf" srcId="0" destId="{676B8BB8-4CE7-267D-D520-DECA4811C8F1}" srcOrd="0" destOrd="0"/>
+  </dgm:cxnLst>
+  <dgm:bg/>
+  <dgm:whole/>
+  <dgm:extLst>
+    <dgm:ext uri="preserve-smartart">
+      <keep xmlns="urn:test">未知数据扩展</keep>
+    </dgm:ext>
+  </dgm:extLst>
+</dgm:dataModel>
+</file>
+
+<file path=ppt/diagrams/data8.xml><?xml version="1.0" encoding="utf-8"?>
+<dgm:dataModel xmlns:dgm="http://schemas.openxmlformats.org/drawingml/2006/diagram" xmlns:a="http://schemas.openxmlformats.org/drawingml/2006/main">
+  <dgm:ptLst>
+    <dgm:pt modelId="0" type="doc">
+      <dgm:prSet/>
+      <dgm:spPr/>
+    </dgm:pt>
+    <dgm:pt modelId="{676B8BB8-4CE7-267D-D520-DECA4811C8F1}">
+      <dgm:prSet/>
+      <dgm:spPr/>
+      <dgm:t>
+        <a:bodyPr/>
+        <a:lstStyle/>
+        <a:p>
+          <a:r>
+            <a:rPr lang="zh-CN" sz="1400"/>
+            <a:t>中心</a:t>
+          </a:r>
+        </a:p>
+      </dgm:t>
+    </dgm:pt>
+    <dgm:pt modelId="{4B54BE3E-8824-0F0C-8816-977EAC1FF1A1}" type="parTrans" cxnId="{777C7715-FE23-B83C-881A-B68874E31C0D}">
+      <dgm:prSet/>
+      <dgm:spPr/>
+    </dgm:pt>
+    <dgm:pt modelId="{BF792F85-12EE-C194-EEC2-59D8816C9DB9}" type="sibTrans" cxnId="{777C7715-FE23-B83C-881A-B68874E31C0D}">
+      <dgm:prSet/>
+      <dgm:spPr/>
+    </dgm:pt>
+    <dgm:pt modelId="{0480A93D-2E9B-094B-89E0-8E01976089AC}">
+      <dgm:prSet/>
+      <dgm:spPr/>
+      <dgm:t>
+        <a:bodyPr/>
+        <a:lstStyle/>
+        <a:p>
+          <a:r>
+            <a:rPr lang="zh-CN" sz="1400"/>
+            <a:t>北</a:t>
+          </a:r>
+        </a:p>
+      </dgm:t>
+    </dgm:pt>
+    <dgm:pt modelId="{B964CCA5-D318-A3FB-454E-56D1C9E279D6}" type="parTrans" cxnId="{A0011C07-9794-2091-CE3A-6B7555144A3B}">
+      <dgm:prSet/>
+      <dgm:spPr/>
+    </dgm:pt>
+    <dgm:pt modelId="{B420699A-2DDB-E17F-EF19-5D92ACDCD3F5}" type="sibTrans" cxnId="{A0011C07-9794-2091-CE3A-6B7555144A3B}">
+      <dgm:prSet/>
+      <dgm:spPr/>
+    </dgm:pt>
+    <dgm:pt modelId="{8721D664-EF60-096A-A559-E1AA6C72CAF1}">
+      <dgm:prSet/>
+      <dgm:spPr/>
+      <dgm:t>
+        <a:bodyPr/>
+        <a:lstStyle/>
+        <a:p>
+          <a:r>
+            <a:rPr lang="zh-CN" sz="1400"/>
+            <a:t>东</a:t>
+          </a:r>
+        </a:p>
+      </dgm:t>
+    </dgm:pt>
+    <dgm:pt modelId="{2ECB2D74-6EAF-4213-0214-A1A202490C85}" type="parTrans" cxnId="{8C1D252E-3E04-9A35-E9E9-4A2E70C4D289}">
+      <dgm:prSet/>
+      <dgm:spPr/>
+    </dgm:pt>
+    <dgm:pt modelId="{E193203F-16E5-A81A-DA7A-CB1E6263F75B}" type="sibTrans" cxnId="{8C1D252E-3E04-9A35-E9E9-4A2E70C4D289}">
+      <dgm:prSet/>
+      <dgm:spPr/>
+    </dgm:pt>
+    <dgm:pt modelId="{88450B08-2EC4-DF2F-DCCD-3A626C6E489B}">
+      <dgm:prSet/>
+      <dgm:spPr/>
+      <dgm:t>
+        <a:bodyPr/>
+        <a:lstStyle/>
+        <a:p>
+          <a:r>
+            <a:rPr lang="zh-CN" sz="1400"/>
+            <a:t>南</a:t>
+          </a:r>
+        </a:p>
+      </dgm:t>
+    </dgm:pt>
+    <dgm:pt modelId="{23D5B1E2-ACC6-204A-08B0-A46EFC43859C}" type="parTrans" cxnId="{9A795A5F-BB92-E034-063D-180FCF1DC882}">
+      <dgm:prSet/>
+      <dgm:spPr/>
+    </dgm:pt>
+    <dgm:pt modelId="{75A33DC7-D312-45BE-114C-E13F373CFA47}" type="sibTrans" cxnId="{9A795A5F-BB92-E034-063D-180FCF1DC882}">
+      <dgm:prSet/>
+      <dgm:spPr/>
+    </dgm:pt>
+    <dgm:pt modelId="{4A8456F1-0E37-6897-78CE-F532AB6A7374}">
+      <dgm:prSet/>
+      <dgm:spPr/>
+      <dgm:t>
+        <a:bodyPr/>
+        <a:lstStyle/>
+        <a:p>
+          <a:r>
+            <a:rPr lang="zh-CN" sz="1400"/>
+            <a:t>西</a:t>
+          </a:r>
+        </a:p>
+      </dgm:t>
+    </dgm:pt>
+    <dgm:pt modelId="{AA90E599-BCAE-0EA2-E1DD-391FC8A5AE74}" type="parTrans" cxnId="{5D498542-7588-3947-C0D0-BC75B4A655BC}">
+      <dgm:prSet/>
+      <dgm:spPr/>
+    </dgm:pt>
+    <dgm:pt modelId="{8D06E3C4-C98F-56FA-F0E8-14727A9DDF13}" type="sibTrans" cxnId="{5D498542-7588-3947-C0D0-BC75B4A655BC}">
+      <dgm:prSet/>
+      <dgm:spPr/>
+    </dgm:pt>
+  </dgm:ptLst>
+  <dgm:cxnLst>
+    <dgm:cxn modelId="{777C7715-FE23-B83C-881A-B68874E31C0D}" srcId="0" destId="{676B8BB8-4CE7-267D-D520-DECA4811C8F1}" srcOrd="0" destOrd="0" parTransId="{4B54BE3E-8824-0F0C-8816-977EAC1FF1A1}" sibTransId="{BF792F85-12EE-C194-EEC2-59D8816C9DB9}"/>
+    <dgm:cxn modelId="{A0011C07-9794-2091-CE3A-6B7555144A3B}" srcId="{676B8BB8-4CE7-267D-D520-DECA4811C8F1}" destId="{0480A93D-2E9B-094B-89E0-8E01976089AC}" srcOrd="0" destOrd="0" parTransId="{B964CCA5-D318-A3FB-454E-56D1C9E279D6}" sibTransId="{B420699A-2DDB-E17F-EF19-5D92ACDCD3F5}"/>
+    <dgm:cxn modelId="{8C1D252E-3E04-9A35-E9E9-4A2E70C4D289}" srcId="{676B8BB8-4CE7-267D-D520-DECA4811C8F1}" destId="{8721D664-EF60-096A-A559-E1AA6C72CAF1}" srcOrd="1" destOrd="0" parTransId="{2ECB2D74-6EAF-4213-0214-A1A202490C85}" sibTransId="{E193203F-16E5-A81A-DA7A-CB1E6263F75B}"/>
+    <dgm:cxn modelId="{9A795A5F-BB92-E034-063D-180FCF1DC882}" srcId="{676B8BB8-4CE7-267D-D520-DECA4811C8F1}" destId="{88450B08-2EC4-DF2F-DCCD-3A626C6E489B}" srcOrd="2" destOrd="0" parTransId="{23D5B1E2-ACC6-204A-08B0-A46EFC43859C}" sibTransId="{75A33DC7-D312-45BE-114C-E13F373CFA47}"/>
+    <dgm:cxn modelId="{5D498542-7588-3947-C0D0-BC75B4A655BC}" srcId="{676B8BB8-4CE7-267D-D520-DECA4811C8F1}" destId="{4A8456F1-0E37-6897-78CE-F532AB6A7374}" srcOrd="3" destOrd="0" parTransId="{AA90E599-BCAE-0EA2-E1DD-391FC8A5AE74}" sibTransId="{8D06E3C4-C98F-56FA-F0E8-14727A9DDF13}"/>
     <dgm:cxn modelId="{405B4841-6753-9D78-1CCF-C7EDFFDD41B1}" type="presOf" srcId="0" destId="{676B8BB8-4CE7-267D-D520-DECA4811C8F1}" srcOrd="0" destOrd="0"/>
   </dgm:cxnLst>
   <dgm:bg/>
@@ -990,6 +1289,34 @@
 </dgm:layoutDef>
 </file>
 
+<file path=ppt/diagrams/layout7.xml><?xml version="1.0" encoding="utf-8"?>
+<dgm:layoutDef xmlns:dgm="http://schemas.openxmlformats.org/drawingml/2006/diagram" xmlns:a="http://schemas.openxmlformats.org/drawingml/2006/main" uniqueId="urn:microsoft.com/office/officeart/2005/8/layout/matrix1">
+  <dgm:title val=""/>
+  <dgm:desc val=""/>
+  <dgm:layoutNode name="root">
+    <dgm:alg type="snake"/>
+    <dgm:shape xmlns:r="http://schemas.openxmlformats.org/officeDocument/2006/relationships" type="none"/>
+    <dgm:presOf/>
+    <dgm:constrLst/>
+    <dgm:ruleLst/>
+  </dgm:layoutNode>
+</dgm:layoutDef>
+</file>
+
+<file path=ppt/diagrams/layout8.xml><?xml version="1.0" encoding="utf-8"?>
+<dgm:layoutDef xmlns:dgm="http://schemas.openxmlformats.org/drawingml/2006/diagram" xmlns:a="http://schemas.openxmlformats.org/drawingml/2006/main" uniqueId="urn:microsoft.com/office/officeart/2005/8/layout/radial1">
+  <dgm:title val=""/>
+  <dgm:desc val=""/>
+  <dgm:layoutNode name="root">
+    <dgm:alg type="sp"/>
+    <dgm:shape xmlns:r="http://schemas.openxmlformats.org/officeDocument/2006/relationships" type="none"/>
+    <dgm:presOf/>
+    <dgm:constrLst/>
+    <dgm:ruleLst/>
+  </dgm:layoutNode>
+</dgm:layoutDef>
+</file>
+
 <file path=ppt/diagrams/quickStyle1.xml><?xml version="1.0" encoding="utf-8"?>
 <dgm:styleDef xmlns:dgm="http://schemas.openxmlformats.org/drawingml/2006/diagram" xmlns:a="http://schemas.openxmlformats.org/drawingml/2006/main" uniqueId="urn:test/style">
   <dgm:title val=""/>
@@ -1091,6 +1418,46 @@
 </file>
 
 <file path=ppt/diagrams/quickStyle6.xml><?xml version="1.0" encoding="utf-8"?>
+<dgm:styleDef xmlns:dgm="http://schemas.openxmlformats.org/drawingml/2006/diagram" xmlns:a="http://schemas.openxmlformats.org/drawingml/2006/main" uniqueId="urn:test/style">
+  <dgm:title val=""/>
+  <dgm:desc val=""/>
+  <dgm:scene3d>
+    <a:camera prst="orthographicFront"/>
+    <a:lightRig rig="threePt" dir="t"/>
+  </dgm:scene3d>
+  <dgm:styleLbl name="node0">
+    <dgm:scene3d>
+      <a:camera prst="orthographicFront"/>
+      <a:lightRig rig="threePt" dir="t"/>
+    </dgm:scene3d>
+    <dgm:sp3d/>
+    <dgm:txPr/>
+    <dgm:style/>
+  </dgm:styleLbl>
+</dgm:styleDef>
+</file>
+
+<file path=ppt/diagrams/quickStyle7.xml><?xml version="1.0" encoding="utf-8"?>
+<dgm:styleDef xmlns:dgm="http://schemas.openxmlformats.org/drawingml/2006/diagram" xmlns:a="http://schemas.openxmlformats.org/drawingml/2006/main" uniqueId="urn:test/style">
+  <dgm:title val=""/>
+  <dgm:desc val=""/>
+  <dgm:scene3d>
+    <a:camera prst="orthographicFront"/>
+    <a:lightRig rig="threePt" dir="t"/>
+  </dgm:scene3d>
+  <dgm:styleLbl name="node0">
+    <dgm:scene3d>
+      <a:camera prst="orthographicFront"/>
+      <a:lightRig rig="threePt" dir="t"/>
+    </dgm:scene3d>
+    <dgm:sp3d/>
+    <dgm:txPr/>
+    <dgm:style/>
+  </dgm:styleLbl>
+</dgm:styleDef>
+</file>
+
+<file path=ppt/diagrams/quickStyle8.xml><?xml version="1.0" encoding="utf-8"?>
 <dgm:styleDef xmlns:dgm="http://schemas.openxmlformats.org/drawingml/2006/diagram" xmlns:a="http://schemas.openxmlformats.org/drawingml/2006/main" uniqueId="urn:test/style">
   <dgm:title val=""/>
   <dgm:desc val=""/>
@@ -1606,6 +1973,150 @@
       <p:graphicFrame>
         <p:nvGraphicFramePr>
           <p:cNvPr id="505" name="SmartArt5"/>
+          <p:cNvGraphicFramePr/>
+          <p:nvPr/>
+        </p:nvGraphicFramePr>
+        <p:xfrm>
+          <a:off x="1143000" y="952500"/>
+          <a:ext cx="9906000" cy="4953000"/>
+        </p:xfrm>
+        <a:graphic>
+          <a:graphicData uri="http://schemas.openxmlformats.org/drawingml/2006/diagram">
+            <dgm:relIds xmlns:dgm="http://schemas.openxmlformats.org/drawingml/2006/diagram" xmlns:r="http://schemas.openxmlformats.org/officeDocument/2006/relationships" r:dm="rId2" r:lo="rId3" r:qs="rId4" r:cs="rId5"/>
+          </a:graphicData>
+        </a:graphic>
+      </p:graphicFrame>
+    </p:spTree>
+  </p:cSld>
+  <p:clrMapOvr>
+    <a:masterClrMapping/>
+  </p:clrMapOvr>
+</p:sld>
+</file>
+
+<file path=ppt/slides/slide7.xml><?xml version="1.0" encoding="utf-8"?>
+<p:sld xmlns:a="http://schemas.openxmlformats.org/drawingml/2006/main" xmlns:r="http://schemas.openxmlformats.org/officeDocument/2006/relationships" xmlns:p="http://schemas.openxmlformats.org/presentationml/2006/main">
+  <p:cSld>
+    <p:spTree>
+      <p:nvGrpSpPr>
+        <p:cNvPr id="1" name=""/>
+        <p:cNvGrpSpPr/>
+        <p:nvPr/>
+      </p:nvGrpSpPr>
+      <p:grpSpPr>
+        <a:xfrm>
+          <a:off x="0" y="0"/>
+          <a:ext cx="0" cy="0"/>
+          <a:chOff x="0" y="0"/>
+          <a:chExt cx="0" cy="0"/>
+        </a:xfrm>
+      </p:grpSpPr>
+      <p:sp>
+        <p:nvSpPr>
+          <p:cNvPr id="107" name="sp"/>
+          <p:cNvSpPr/>
+          <p:nvPr/>
+        </p:nvSpPr>
+        <p:spPr>
+          <a:xfrm>
+            <a:off x="381000" y="228600"/>
+            <a:ext cx="8572500" cy="323850"/>
+          </a:xfrm>
+          <a:prstGeom prst="rect">
+            <a:avLst/>
+          </a:prstGeom>
+          <a:noFill/>
+        </p:spPr>
+        <p:txBody>
+          <a:bodyPr anchor="ctr"/>
+          <a:lstStyle/>
+          <a:p>
+            <a:r>
+              <a:rPr sz="1600" b="1">
+                <a:solidFill>
+                  <a:schemeClr val="tx2"/>
+                </a:solidFill>
+              </a:rPr>
+              <a:t>无 drawing · 矩阵（matrix1→snake）</a:t>
+            </a:r>
+          </a:p>
+        </p:txBody>
+      </p:sp>
+      <p:graphicFrame>
+        <p:nvGraphicFramePr>
+          <p:cNvPr id="506" name="SmartArt6"/>
+          <p:cNvGraphicFramePr/>
+          <p:nvPr/>
+        </p:nvGraphicFramePr>
+        <p:xfrm>
+          <a:off x="1143000" y="952500"/>
+          <a:ext cx="9906000" cy="4953000"/>
+        </p:xfrm>
+        <a:graphic>
+          <a:graphicData uri="http://schemas.openxmlformats.org/drawingml/2006/diagram">
+            <dgm:relIds xmlns:dgm="http://schemas.openxmlformats.org/drawingml/2006/diagram" xmlns:r="http://schemas.openxmlformats.org/officeDocument/2006/relationships" r:dm="rId2" r:lo="rId3" r:qs="rId4" r:cs="rId5"/>
+          </a:graphicData>
+        </a:graphic>
+      </p:graphicFrame>
+    </p:spTree>
+  </p:cSld>
+  <p:clrMapOvr>
+    <a:masterClrMapping/>
+  </p:clrMapOvr>
+</p:sld>
+</file>
+
+<file path=ppt/slides/slide8.xml><?xml version="1.0" encoding="utf-8"?>
+<p:sld xmlns:a="http://schemas.openxmlformats.org/drawingml/2006/main" xmlns:r="http://schemas.openxmlformats.org/officeDocument/2006/relationships" xmlns:p="http://schemas.openxmlformats.org/presentationml/2006/main">
+  <p:cSld>
+    <p:spTree>
+      <p:nvGrpSpPr>
+        <p:cNvPr id="1" name=""/>
+        <p:cNvGrpSpPr/>
+        <p:nvPr/>
+      </p:nvGrpSpPr>
+      <p:grpSpPr>
+        <a:xfrm>
+          <a:off x="0" y="0"/>
+          <a:ext cx="0" cy="0"/>
+          <a:chOff x="0" y="0"/>
+          <a:chExt cx="0" cy="0"/>
+        </a:xfrm>
+      </p:grpSpPr>
+      <p:sp>
+        <p:nvSpPr>
+          <p:cNvPr id="108" name="sp"/>
+          <p:cNvSpPr/>
+          <p:nvPr/>
+        </p:nvSpPr>
+        <p:spPr>
+          <a:xfrm>
+            <a:off x="381000" y="228600"/>
+            <a:ext cx="8572500" cy="323850"/>
+          </a:xfrm>
+          <a:prstGeom prst="rect">
+            <a:avLst/>
+          </a:prstGeom>
+          <a:noFill/>
+        </p:spPr>
+        <p:txBody>
+          <a:bodyPr anchor="ctr"/>
+          <a:lstStyle/>
+          <a:p>
+            <a:r>
+              <a:rPr sz="1600" b="1">
+                <a:solidFill>
+                  <a:schemeClr val="tx2"/>
+                </a:solidFill>
+              </a:rPr>
+              <a:t>无 drawing · 径向（radial1）</a:t>
+            </a:r>
+          </a:p>
+        </p:txBody>
+      </p:sp>
+      <p:graphicFrame>
+        <p:nvGraphicFramePr>
+          <p:cNvPr id="507" name="SmartArt7"/>
           <p:cNvGraphicFramePr/>
           <p:nvPr/>
         </p:nvGraphicFramePr>

</xml_diff>